<commit_message>
Update contest package: refreshed source copy, regenerated PDF/deck with 373/15 gate, manifest v2.0
</commit_message>
<xml_diff>
--- a/submissions/Track2-Physics-First-AI-NuclidePath/NuclidePath_Track2_Deck.pptx
+++ b/submissions/Track2-Physics-First-AI-NuclidePath/NuclidePath_Track2_Deck.pptx
@@ -950,7 +950,7 @@
           <a:p>
             <a:r>
               <a:rPr lang="en-US" dirty="0"/>
-              <a:t>Quote measured numbers only. The current AMD v0.3 run is verified; the equality check compares physical runs, not timestamped memory files.</a:t>
+              <a:t>Quote measured numbers only. The dated AMD v0.3 core-platform snapshot is verified; the equality check compares physical runs, not timestamped memory files.</a:t>
             </a:r>
             <a:endParaRPr lang="en-US" dirty="0"/>
           </a:p>
@@ -2263,7 +2263,7 @@
                 <a:ea typeface="Liberation Mono" pitchFamily="34" charset="-122"/>
                 <a:cs typeface="Liberation Mono" pitchFamily="34" charset="-120"/>
               </a:rPr>
-              <a:t>356/15</a:t>
+              <a:t>373/15</a:t>
             </a:r>
             <a:endParaRPr lang="en-US" sz="3600" dirty="0"/>
           </a:p>

</xml_diff>

<commit_message>
Sync contest deck to main 13eb2c8 (388 AMD post-merge claim)
</commit_message>
<xml_diff>
--- a/submissions/Track2-Physics-First-AI-NuclidePath/NuclidePath_Track2_Deck.pptx
+++ b/submissions/Track2-Physics-First-AI-NuclidePath/NuclidePath_Track2_Deck.pptx
@@ -8573,7 +8573,7 @@
                 <a:ea typeface="Liberation Sans" pitchFamily="34" charset="-122"/>
                 <a:cs typeface="Liberation Sans" pitchFamily="34" charset="-120"/>
               </a:rPr>
-              <a:t>231 AMD core tests + FP64 parity + SHA-256</a:t>
+              <a:t>388 AMD post-merge tests + FP64 parity + SHA-256</a:t>
             </a:r>
             <a:endParaRPr lang="en-US" sz="1600" dirty="0"/>
           </a:p>
@@ -8926,7 +8926,7 @@
                 <a:ea typeface="Liberation Mono" pitchFamily="34" charset="-122"/>
                 <a:cs typeface="Liberation Mono" pitchFamily="34" charset="-120"/>
               </a:rPr>
-              <a:t>231</a:t>
+              <a:t>388</a:t>
             </a:r>
             <a:endParaRPr lang="en-US" sz="3600" dirty="0"/>
           </a:p>
@@ -8967,7 +8967,7 @@
                 <a:ea typeface="Liberation Sans" pitchFamily="34" charset="-122"/>
                 <a:cs typeface="Liberation Sans" pitchFamily="34" charset="-120"/>
               </a:rPr>
-              <a:t>AMD core tests</a:t>
+              <a:t>AMD tests (post-merge)</a:t>
             </a:r>
             <a:endParaRPr lang="en-US" sz="1100" dirty="0"/>
           </a:p>

</xml_diff>

<commit_message>
Sync contest to main b81209e: deck with multicomponent bridge card, source release aligned to f18536a
</commit_message>
<xml_diff>
--- a/submissions/Track2-Physics-First-AI-NuclidePath/NuclidePath_Track2_Deck.pptx
+++ b/submissions/Track2-Physics-First-AI-NuclidePath/NuclidePath_Track2_Deck.pptx
@@ -951,7 +951,7 @@
           <a:p>
             <a:r>
               <a:rPr lang="en-US" dirty="0"/>
-              <a:t>Describe the formulas and say validation means software/formula verification, not regulatory validation.</a:t>
+              <a:t>Describe the formulas and say validation means software/formula verification, not regulatory validation. The multicomponent K/Na/Ca/Mg bridge is opt-in and process-qualified only; the canonical Cs–K GCS path remains authoritative.</a:t>
             </a:r>
             <a:endParaRPr lang="en-US" dirty="0"/>
           </a:p>
@@ -6774,7 +6774,139 @@
       </p:sp>
       <p:sp>
         <p:nvSpPr>
-          <p:cNvPr id="21" name="Text 19"/>
+          <p:cNvPr id="21" name="Shape 19"/>
+          <p:cNvSpPr/>
+          <p:nvPr/>
+        </p:nvSpPr>
+        <p:spPr>
+          <a:xfrm>
+            <a:off x="6839712" y="5559552"/>
+            <a:ext cx="4736592" cy="777240"/>
+          </a:xfrm>
+          <a:prstGeom prst="rect">
+            <a:avLst/>
+          </a:prstGeom>
+          <a:solidFill>
+            <a:srgbClr val="15171A"/>
+          </a:solidFill>
+          <a:ln w="12700">
+            <a:solidFill>
+              <a:srgbClr val="363A40"/>
+            </a:solidFill>
+            <a:prstDash val="solid"/>
+          </a:ln>
+        </p:spPr>
+      </p:sp>
+      <p:sp>
+        <p:nvSpPr>
+          <p:cNvPr id="22" name="Shape 20"/>
+          <p:cNvSpPr/>
+          <p:nvPr/>
+        </p:nvSpPr>
+        <p:spPr>
+          <a:xfrm>
+            <a:off x="6839712" y="5559552"/>
+            <a:ext cx="73152" cy="777240"/>
+          </a:xfrm>
+          <a:prstGeom prst="rect">
+            <a:avLst/>
+          </a:prstGeom>
+          <a:solidFill>
+            <a:srgbClr val="BE95FF"/>
+          </a:solidFill>
+          <a:ln w="12700">
+            <a:solidFill>
+              <a:srgbClr val="BE95FF"/>
+            </a:solidFill>
+            <a:prstDash val="solid"/>
+          </a:ln>
+        </p:spPr>
+      </p:sp>
+      <p:sp>
+        <p:nvSpPr>
+          <p:cNvPr id="23" name="Text 21"/>
+          <p:cNvSpPr/>
+          <p:nvPr/>
+        </p:nvSpPr>
+        <p:spPr>
+          <a:xfrm>
+            <a:off x="7059168" y="5724144"/>
+            <a:ext cx="4389120" cy="256032"/>
+          </a:xfrm>
+          <a:prstGeom prst="rect">
+            <a:avLst/>
+          </a:prstGeom>
+          <a:noFill/>
+          <a:ln/>
+        </p:spPr>
+        <p:txBody>
+          <a:bodyPr wrap="square" lIns="0" tIns="0" rIns="0" bIns="0" rtlCol="0" anchor="ctr">
+            <a:normAutofit/>
+          </a:bodyPr>
+          <a:lstStyle/>
+          <a:p>
+            <a:pPr algn="l" indent="0" marL="0">
+              <a:buNone/>
+            </a:pPr>
+            <a:r>
+              <a:rPr lang="en-US" sz="1400" b="1" dirty="0">
+                <a:solidFill>
+                  <a:srgbClr val="F5F7FA"/>
+                </a:solidFill>
+                <a:latin typeface="Liberation Sans" pitchFamily="34" charset="0"/>
+                <a:ea typeface="Liberation Sans" pitchFamily="34" charset="-122"/>
+                <a:cs typeface="Liberation Sans" pitchFamily="34" charset="-120"/>
+              </a:rPr>
+              <a:t>Multicomponent bridge (opt-in)</a:t>
+            </a:r>
+            <a:endParaRPr lang="en-US" sz="1400" dirty="0"/>
+          </a:p>
+        </p:txBody>
+      </p:sp>
+      <p:sp>
+        <p:nvSpPr>
+          <p:cNvPr id="24" name="Text 22"/>
+          <p:cNvSpPr/>
+          <p:nvPr/>
+        </p:nvSpPr>
+        <p:spPr>
+          <a:xfrm>
+            <a:off x="7059168" y="6062472"/>
+            <a:ext cx="4389120" cy="137160"/>
+          </a:xfrm>
+          <a:prstGeom prst="rect">
+            <a:avLst/>
+          </a:prstGeom>
+          <a:noFill/>
+          <a:ln/>
+        </p:spPr>
+        <p:txBody>
+          <a:bodyPr wrap="square" lIns="0" tIns="0" rIns="0" bIns="0" rtlCol="0" anchor="t">
+            <a:normAutofit/>
+          </a:bodyPr>
+          <a:lstStyle/>
+          <a:p>
+            <a:pPr algn="l" indent="0" marL="0">
+              <a:buNone/>
+            </a:pPr>
+            <a:r>
+              <a:rPr lang="en-US" sz="1150" dirty="0">
+                <a:solidFill>
+                  <a:srgbClr val="A7ADB5"/>
+                </a:solidFill>
+                <a:latin typeface="Liberation Sans" pitchFamily="34" charset="0"/>
+                <a:ea typeface="Liberation Sans" pitchFamily="34" charset="-122"/>
+                <a:cs typeface="Liberation Sans" pitchFamily="34" charset="-120"/>
+              </a:rPr>
+              <a:t>GCS K/Na competition + NH₄ on FES; extended K/Na/Ca/Mg path is process-qualified, not promoted.</a:t>
+            </a:r>
+            <a:endParaRPr lang="en-US" sz="1150" dirty="0"/>
+          </a:p>
+        </p:txBody>
+      </p:sp>
+      <p:sp>
+        <p:nvSpPr>
+          <p:cNvPr id="25" name="Text 23"/>
           <p:cNvSpPr/>
           <p:nvPr/>
         </p:nvSpPr>
@@ -6815,7 +6947,7 @@
       </p:sp>
       <p:sp>
         <p:nvSpPr>
-          <p:cNvPr id="22" name="Text 20"/>
+          <p:cNvPr id="26" name="Text 24"/>
           <p:cNvSpPr/>
           <p:nvPr/>
         </p:nvSpPr>

</xml_diff>

<commit_message>
Sync contest to main 2162605: complete source copy, refreshed PDF/deck, docs aligned to df8f028 content head
</commit_message>
<xml_diff>
--- a/submissions/Track2-Physics-First-AI-NuclidePath/NuclidePath_Track2_Deck.pptx
+++ b/submissions/Track2-Physics-First-AI-NuclidePath/NuclidePath_Track2_Deck.pptx
@@ -599,7 +599,7 @@
           <a:p>
             <a:r>
               <a:rPr lang="en-US" dirty="0"/>
-              <a:t>Close on current evidence: local, tested, reproducible and honest about scope. The 137.09× result is the measured device-resident FP64 primary-GCS to receptor pipeline versus the scalar reference, not environmental validation.</a:t>
+              <a:t>Close on current evidence: local, tested, reproducible and honest about scope. The 132.8× result is the measured device-resident FP64 primary-GCS to receptor pipeline versus the scalar reference, reproduced in the 5 August post-merge AMD rerun alongside the 388 passing tests (the 28 July core snapshot measured 137.09× on the same pipeline). This is a performance result, not environmental validation.</a:t>
             </a:r>
             <a:endParaRPr lang="en-US" dirty="0"/>
           </a:p>
@@ -2393,7 +2393,7 @@
                 <a:ea typeface="Liberation Sans" pitchFamily="34" charset="-122"/>
                 <a:cs typeface="Liberation Sans" pitchFamily="34" charset="-120"/>
               </a:rPr>
-              <a:t>latest PR gate</a:t>
+              <a:t>latest CI gate</a:t>
             </a:r>
             <a:endParaRPr lang="en-US" sz="1100" dirty="0"/>
           </a:p>
@@ -3123,7 +3123,7 @@
                 <a:ea typeface="Liberation Mono" pitchFamily="34" charset="-122"/>
                 <a:cs typeface="Liberation Mono" pitchFamily="34" charset="-120"/>
               </a:rPr>
-              <a:t>137.09×</a:t>
+              <a:t>132.8×</a:t>
             </a:r>
             <a:endParaRPr lang="en-US" sz="3600" dirty="0"/>
           </a:p>
@@ -3164,7 +3164,7 @@
                 <a:ea typeface="Liberation Sans" pitchFamily="34" charset="-122"/>
                 <a:cs typeface="Liberation Sans" pitchFamily="34" charset="-120"/>
               </a:rPr>
-              <a:t>FP64 platform</a:t>
+              <a:t>FP64 platform (post-merge)</a:t>
             </a:r>
             <a:endParaRPr lang="en-US" sz="1100" dirty="0"/>
           </a:p>

</xml_diff>